<commit_message>
* [Readme] Fix some Typos.
</commit_message>
<xml_diff>
--- a/Doc/CnPack IDE Wizards Presentation.pptx
+++ b/Doc/CnPack IDE Wizards Presentation.pptx
@@ -5177,25 +5177,57 @@
           <a:lstStyle/>
           <a:p>
             <a:r>
-              <a:rPr lang="en-US" altLang="zh-CN"/>
-              <a:t>Current Version of CnPack IDE Wizards: 0.8.2</a:t>
-            </a:r>
-          </a:p>
-          <a:p>
-            <a:r>
-              <a:rPr lang="en-US" altLang="zh-CN">
+              <a:rPr lang="en-US" altLang="zh-CN" dirty="0"/>
+              <a:t>Current Version of </a:t>
+            </a:r>
+            <a:r>
+              <a:rPr lang="en-US" altLang="zh-CN" dirty="0" err="1"/>
+              <a:t>CnPack</a:t>
+            </a:r>
+            <a:r>
+              <a:rPr lang="en-US" altLang="zh-CN" dirty="0"/>
+              <a:t> IDE Wizards: 0.8.2</a:t>
+            </a:r>
+          </a:p>
+          <a:p>
+            <a:r>
+              <a:rPr lang="en-US" altLang="zh-CN" dirty="0">
                 <a:solidFill>
                   <a:srgbClr val="FFFF00"/>
                 </a:solidFill>
               </a:rPr>
-              <a:t>Zhou Jingyu,</a:t>
-            </a:r>
-            <a:r>
-              <a:rPr lang="en-US" altLang="zh-CN"/>
-              <a:t> the Initiator, Administrator, Main Designer and Author of CnPack IDE Wizards is Elected as an </a:t>
-            </a:r>
-            <a:r>
-              <a:rPr lang="en-US" altLang="zh-CN">
+              <a:t>Zhou </a:t>
+            </a:r>
+            <a:r>
+              <a:rPr lang="en-US" altLang="zh-CN" dirty="0" err="1">
+                <a:solidFill>
+                  <a:srgbClr val="FFFF00"/>
+                </a:solidFill>
+              </a:rPr>
+              <a:t>Jingyu</a:t>
+            </a:r>
+            <a:r>
+              <a:rPr lang="en-US" altLang="zh-CN" dirty="0">
+                <a:solidFill>
+                  <a:srgbClr val="FFFF00"/>
+                </a:solidFill>
+              </a:rPr>
+              <a:t>,</a:t>
+            </a:r>
+            <a:r>
+              <a:rPr lang="en-US" altLang="zh-CN" dirty="0"/>
+              <a:t> the Initiator, Administrator, Main Designer and Author of </a:t>
+            </a:r>
+            <a:r>
+              <a:rPr lang="en-US" altLang="zh-CN" dirty="0" err="1"/>
+              <a:t>CnPack</a:t>
+            </a:r>
+            <a:r>
+              <a:rPr lang="en-US" altLang="zh-CN" dirty="0"/>
+              <a:t> IDE Wizards is Elected as an </a:t>
+            </a:r>
+            <a:r>
+              <a:rPr lang="en-US" altLang="zh-CN" dirty="0">
                 <a:solidFill>
                   <a:srgbClr val="FFFF00"/>
                 </a:solidFill>
@@ -5203,10 +5235,10 @@
               <a:t>Borland Expert </a:t>
             </a:r>
             <a:r>
-              <a:rPr lang="en-US" altLang="zh-CN"/>
+              <a:rPr lang="en-US" altLang="zh-CN" dirty="0"/>
               <a:t>in 2003</a:t>
             </a:r>
-            <a:endParaRPr lang="en-US" altLang="zh-CN">
+            <a:endParaRPr lang="en-US" altLang="zh-CN" dirty="0">
               <a:solidFill>
                 <a:schemeClr val="tx1"/>
               </a:solidFill>
@@ -5214,8 +5246,16 @@
           </a:p>
           <a:p>
             <a:r>
-              <a:rPr lang="en-US" altLang="zh-CN"/>
-              <a:t>Users Cover Home and Aboard. CnPack IDE Users are More than 4300 by Upgrade-checking Statistics.</a:t>
+              <a:rPr lang="en-US" altLang="zh-CN" dirty="0"/>
+              <a:t>Users Cover Home and Abroad. </a:t>
+            </a:r>
+            <a:r>
+              <a:rPr lang="en-US" altLang="zh-CN" dirty="0" err="1"/>
+              <a:t>CnPack</a:t>
+            </a:r>
+            <a:r>
+              <a:rPr lang="en-US" altLang="zh-CN" dirty="0"/>
+              <a:t> IDE Users are More than 4300 by Upgrade-checking Statistics.</a:t>
             </a:r>
           </a:p>
         </p:txBody>

</xml_diff>